<commit_message>
added chatbot and ai
</commit_message>
<xml_diff>
--- a/Capstone_Life_Insurance_Presentation.pptx
+++ b/Capstone_Life_Insurance_Presentation.pptx
@@ -278,6 +278,13 @@
           </p:nvPr>
         </p:nvSpPr>
         <p:spPr/>
+        <p:txBody>
+          <a:bodyPr/>
+          <a:lstStyle/>
+          <a:p>
+            <a:endParaRPr lang="en-IN"/>
+          </a:p>
+        </p:txBody>
       </p:sp>
       <p:sp>
         <p:nvSpPr>
@@ -362,6 +369,13 @@
           </p:nvPr>
         </p:nvSpPr>
         <p:spPr/>
+        <p:txBody>
+          <a:bodyPr/>
+          <a:lstStyle/>
+          <a:p>
+            <a:endParaRPr lang="en-IN"/>
+          </a:p>
+        </p:txBody>
       </p:sp>
       <p:sp>
         <p:nvSpPr>
@@ -446,6 +460,13 @@
           </p:nvPr>
         </p:nvSpPr>
         <p:spPr/>
+        <p:txBody>
+          <a:bodyPr/>
+          <a:lstStyle/>
+          <a:p>
+            <a:endParaRPr lang="en-IN"/>
+          </a:p>
+        </p:txBody>
       </p:sp>
       <p:sp>
         <p:nvSpPr>
@@ -530,6 +551,13 @@
           </p:nvPr>
         </p:nvSpPr>
         <p:spPr/>
+        <p:txBody>
+          <a:bodyPr/>
+          <a:lstStyle/>
+          <a:p>
+            <a:endParaRPr lang="en-IN"/>
+          </a:p>
+        </p:txBody>
       </p:sp>
       <p:sp>
         <p:nvSpPr>
@@ -614,6 +642,13 @@
           </p:nvPr>
         </p:nvSpPr>
         <p:spPr/>
+        <p:txBody>
+          <a:bodyPr/>
+          <a:lstStyle/>
+          <a:p>
+            <a:endParaRPr lang="en-IN"/>
+          </a:p>
+        </p:txBody>
       </p:sp>
       <p:sp>
         <p:nvSpPr>
@@ -698,6 +733,13 @@
           </p:nvPr>
         </p:nvSpPr>
         <p:spPr/>
+        <p:txBody>
+          <a:bodyPr/>
+          <a:lstStyle/>
+          <a:p>
+            <a:endParaRPr lang="en-IN"/>
+          </a:p>
+        </p:txBody>
       </p:sp>
       <p:sp>
         <p:nvSpPr>
@@ -782,6 +824,13 @@
           </p:nvPr>
         </p:nvSpPr>
         <p:spPr/>
+        <p:txBody>
+          <a:bodyPr/>
+          <a:lstStyle/>
+          <a:p>
+            <a:endParaRPr lang="en-IN"/>
+          </a:p>
+        </p:txBody>
       </p:sp>
       <p:sp>
         <p:nvSpPr>
@@ -866,6 +915,13 @@
           </p:nvPr>
         </p:nvSpPr>
         <p:spPr/>
+        <p:txBody>
+          <a:bodyPr/>
+          <a:lstStyle/>
+          <a:p>
+            <a:endParaRPr lang="en-IN"/>
+          </a:p>
+        </p:txBody>
       </p:sp>
       <p:sp>
         <p:nvSpPr>
@@ -950,6 +1006,13 @@
           </p:nvPr>
         </p:nvSpPr>
         <p:spPr/>
+        <p:txBody>
+          <a:bodyPr/>
+          <a:lstStyle/>
+          <a:p>
+            <a:endParaRPr lang="en-IN"/>
+          </a:p>
+        </p:txBody>
       </p:sp>
       <p:sp>
         <p:nvSpPr>
@@ -1034,6 +1097,13 @@
           </p:nvPr>
         </p:nvSpPr>
         <p:spPr/>
+        <p:txBody>
+          <a:bodyPr/>
+          <a:lstStyle/>
+          <a:p>
+            <a:endParaRPr lang="en-IN"/>
+          </a:p>
+        </p:txBody>
       </p:sp>
       <p:sp>
         <p:nvSpPr>
@@ -1118,6 +1188,13 @@
           </p:nvPr>
         </p:nvSpPr>
         <p:spPr/>
+        <p:txBody>
+          <a:bodyPr/>
+          <a:lstStyle/>
+          <a:p>
+            <a:endParaRPr lang="en-IN"/>
+          </a:p>
+        </p:txBody>
       </p:sp>
       <p:sp>
         <p:nvSpPr>
@@ -1202,6 +1279,13 @@
           </p:nvPr>
         </p:nvSpPr>
         <p:spPr/>
+        <p:txBody>
+          <a:bodyPr/>
+          <a:lstStyle/>
+          <a:p>
+            <a:endParaRPr lang="en-IN"/>
+          </a:p>
+        </p:txBody>
       </p:sp>
       <p:sp>
         <p:nvSpPr>
@@ -1286,6 +1370,13 @@
           </p:nvPr>
         </p:nvSpPr>
         <p:spPr/>
+        <p:txBody>
+          <a:bodyPr/>
+          <a:lstStyle/>
+          <a:p>
+            <a:endParaRPr lang="en-IN"/>
+          </a:p>
+        </p:txBody>
       </p:sp>
       <p:sp>
         <p:nvSpPr>
@@ -1727,6 +1818,13 @@
             <a:prstDash val="solid"/>
           </a:ln>
         </p:spPr>
+        <p:txBody>
+          <a:bodyPr/>
+          <a:lstStyle/>
+          <a:p>
+            <a:endParaRPr lang="en-IN"/>
+          </a:p>
+        </p:txBody>
       </p:sp>
       <p:sp>
         <p:nvSpPr>
@@ -1752,6 +1850,13 @@
             <a:prstDash val="solid"/>
           </a:ln>
         </p:spPr>
+        <p:txBody>
+          <a:bodyPr/>
+          <a:lstStyle/>
+          <a:p>
+            <a:endParaRPr lang="en-IN"/>
+          </a:p>
+        </p:txBody>
       </p:sp>
       <p:sp>
         <p:nvSpPr>
@@ -1772,6 +1877,13 @@
           </a:solidFill>
           <a:ln/>
         </p:spPr>
+        <p:txBody>
+          <a:bodyPr/>
+          <a:lstStyle/>
+          <a:p>
+            <a:endParaRPr lang="en-IN"/>
+          </a:p>
+        </p:txBody>
       </p:sp>
       <p:pic>
         <p:nvPicPr>
@@ -1921,6 +2033,13 @@
           </a:solidFill>
           <a:ln/>
         </p:spPr>
+        <p:txBody>
+          <a:bodyPr/>
+          <a:lstStyle/>
+          <a:p>
+            <a:endParaRPr lang="en-IN"/>
+          </a:p>
+        </p:txBody>
       </p:sp>
       <p:sp>
         <p:nvSpPr>
@@ -1977,6 +2096,13 @@
           </a:solidFill>
           <a:ln/>
         </p:spPr>
+        <p:txBody>
+          <a:bodyPr/>
+          <a:lstStyle/>
+          <a:p>
+            <a:endParaRPr lang="en-IN"/>
+          </a:p>
+        </p:txBody>
       </p:sp>
       <p:sp>
         <p:nvSpPr>
@@ -2008,7 +2134,7 @@
                   <a:srgbClr val="FE3082"/>
                 </a:solidFill>
               </a:rPr>
-              <a:t>Angular 20</a:t>
+              <a:t>Angular </a:t>
             </a:r>
             <a:endParaRPr lang="en-US" sz="750" dirty="0"/>
           </a:p>
@@ -2033,6 +2159,13 @@
           </a:solidFill>
           <a:ln/>
         </p:spPr>
+        <p:txBody>
+          <a:bodyPr/>
+          <a:lstStyle/>
+          <a:p>
+            <a:endParaRPr lang="en-IN"/>
+          </a:p>
+        </p:txBody>
       </p:sp>
       <p:sp>
         <p:nvSpPr>
@@ -2152,6 +2285,13 @@
           </a:solidFill>
           <a:ln/>
         </p:spPr>
+        <p:txBody>
+          <a:bodyPr/>
+          <a:lstStyle/>
+          <a:p>
+            <a:endParaRPr lang="en-IN"/>
+          </a:p>
+        </p:txBody>
       </p:sp>
       <p:sp>
         <p:nvSpPr>
@@ -2352,6 +2492,13 @@
           </a:solidFill>
           <a:ln/>
         </p:spPr>
+        <p:txBody>
+          <a:bodyPr/>
+          <a:lstStyle/>
+          <a:p>
+            <a:endParaRPr lang="en-IN"/>
+          </a:p>
+        </p:txBody>
       </p:sp>
       <p:sp>
         <p:nvSpPr>
@@ -2413,14 +2560,6 @@
             <a:pPr marL="0" indent="0">
               <a:buNone/>
             </a:pPr>
-            <a:r>
-              <a:rPr lang="en-US" sz="1000" i="1" dirty="0">
-                <a:solidFill>
-                  <a:srgbClr val="A8024F"/>
-                </a:solidFill>
-              </a:rPr>
-              <a:t>Plan types with specialized financial instruments</a:t>
-            </a:r>
             <a:endParaRPr lang="en-US" sz="1000" dirty="0"/>
           </a:p>
         </p:txBody>
@@ -2444,6 +2583,13 @@
           </a:solidFill>
           <a:ln/>
         </p:spPr>
+        <p:txBody>
+          <a:bodyPr/>
+          <a:lstStyle/>
+          <a:p>
+            <a:endParaRPr lang="en-IN"/>
+          </a:p>
+        </p:txBody>
       </p:sp>
       <p:sp>
         <p:nvSpPr>
@@ -2507,6 +2653,13 @@
             </a:outerShdw>
           </a:effectLst>
         </p:spPr>
+        <p:txBody>
+          <a:bodyPr/>
+          <a:lstStyle/>
+          <a:p>
+            <a:endParaRPr lang="en-IN"/>
+          </a:p>
+        </p:txBody>
       </p:sp>
       <p:sp>
         <p:nvSpPr>
@@ -2527,6 +2680,13 @@
           </a:solidFill>
           <a:ln/>
         </p:spPr>
+        <p:txBody>
+          <a:bodyPr/>
+          <a:lstStyle/>
+          <a:p>
+            <a:endParaRPr lang="en-IN"/>
+          </a:p>
+        </p:txBody>
       </p:sp>
       <p:sp>
         <p:nvSpPr>
@@ -2655,6 +2815,13 @@
           </a:solidFill>
           <a:ln/>
         </p:spPr>
+        <p:txBody>
+          <a:bodyPr/>
+          <a:lstStyle/>
+          <a:p>
+            <a:endParaRPr lang="en-IN"/>
+          </a:p>
+        </p:txBody>
       </p:sp>
       <p:sp>
         <p:nvSpPr>
@@ -2718,6 +2885,13 @@
             </a:outerShdw>
           </a:effectLst>
         </p:spPr>
+        <p:txBody>
+          <a:bodyPr/>
+          <a:lstStyle/>
+          <a:p>
+            <a:endParaRPr lang="en-IN"/>
+          </a:p>
+        </p:txBody>
       </p:sp>
       <p:sp>
         <p:nvSpPr>
@@ -2738,6 +2912,13 @@
           </a:solidFill>
           <a:ln/>
         </p:spPr>
+        <p:txBody>
+          <a:bodyPr/>
+          <a:lstStyle/>
+          <a:p>
+            <a:endParaRPr lang="en-IN"/>
+          </a:p>
+        </p:txBody>
       </p:sp>
       <p:sp>
         <p:nvSpPr>
@@ -2866,6 +3047,13 @@
           </a:solidFill>
           <a:ln/>
         </p:spPr>
+        <p:txBody>
+          <a:bodyPr/>
+          <a:lstStyle/>
+          <a:p>
+            <a:endParaRPr lang="en-IN"/>
+          </a:p>
+        </p:txBody>
       </p:sp>
       <p:sp>
         <p:nvSpPr>
@@ -2929,6 +3117,13 @@
             </a:outerShdw>
           </a:effectLst>
         </p:spPr>
+        <p:txBody>
+          <a:bodyPr/>
+          <a:lstStyle/>
+          <a:p>
+            <a:endParaRPr lang="en-IN"/>
+          </a:p>
+        </p:txBody>
       </p:sp>
       <p:sp>
         <p:nvSpPr>
@@ -2949,6 +3144,13 @@
           </a:solidFill>
           <a:ln/>
         </p:spPr>
+        <p:txBody>
+          <a:bodyPr/>
+          <a:lstStyle/>
+          <a:p>
+            <a:endParaRPr lang="en-IN"/>
+          </a:p>
+        </p:txBody>
       </p:sp>
       <p:sp>
         <p:nvSpPr>
@@ -3077,6 +3279,13 @@
           </a:solidFill>
           <a:ln/>
         </p:spPr>
+        <p:txBody>
+          <a:bodyPr/>
+          <a:lstStyle/>
+          <a:p>
+            <a:endParaRPr lang="en-IN"/>
+          </a:p>
+        </p:txBody>
       </p:sp>
       <p:sp>
         <p:nvSpPr>
@@ -3140,6 +3349,13 @@
             </a:outerShdw>
           </a:effectLst>
         </p:spPr>
+        <p:txBody>
+          <a:bodyPr/>
+          <a:lstStyle/>
+          <a:p>
+            <a:endParaRPr lang="en-IN"/>
+          </a:p>
+        </p:txBody>
       </p:sp>
       <p:sp>
         <p:nvSpPr>
@@ -3160,6 +3376,13 @@
           </a:solidFill>
           <a:ln/>
         </p:spPr>
+        <p:txBody>
+          <a:bodyPr/>
+          <a:lstStyle/>
+          <a:p>
+            <a:endParaRPr lang="en-IN"/>
+          </a:p>
+        </p:txBody>
       </p:sp>
       <p:sp>
         <p:nvSpPr>
@@ -3288,6 +3511,13 @@
           </a:solidFill>
           <a:ln/>
         </p:spPr>
+        <p:txBody>
+          <a:bodyPr/>
+          <a:lstStyle/>
+          <a:p>
+            <a:endParaRPr lang="en-IN"/>
+          </a:p>
+        </p:txBody>
       </p:sp>
       <p:sp>
         <p:nvSpPr>
@@ -3396,6 +3626,13 @@
             </a:outerShdw>
           </a:effectLst>
         </p:spPr>
+        <p:txBody>
+          <a:bodyPr/>
+          <a:lstStyle/>
+          <a:p>
+            <a:endParaRPr lang="en-IN"/>
+          </a:p>
+        </p:txBody>
       </p:sp>
       <p:sp>
         <p:nvSpPr>
@@ -3416,6 +3653,13 @@
           </a:solidFill>
           <a:ln/>
         </p:spPr>
+        <p:txBody>
+          <a:bodyPr/>
+          <a:lstStyle/>
+          <a:p>
+            <a:endParaRPr lang="en-IN"/>
+          </a:p>
+        </p:txBody>
       </p:sp>
       <p:sp>
         <p:nvSpPr>
@@ -3500,6 +3744,13 @@
           </a:solidFill>
           <a:ln/>
         </p:spPr>
+        <p:txBody>
+          <a:bodyPr/>
+          <a:lstStyle/>
+          <a:p>
+            <a:endParaRPr lang="en-IN"/>
+          </a:p>
+        </p:txBody>
       </p:sp>
       <p:sp>
         <p:nvSpPr>
@@ -3563,6 +3814,13 @@
             </a:outerShdw>
           </a:effectLst>
         </p:spPr>
+        <p:txBody>
+          <a:bodyPr/>
+          <a:lstStyle/>
+          <a:p>
+            <a:endParaRPr lang="en-IN"/>
+          </a:p>
+        </p:txBody>
       </p:sp>
       <p:sp>
         <p:nvSpPr>
@@ -3583,6 +3841,13 @@
           </a:solidFill>
           <a:ln/>
         </p:spPr>
+        <p:txBody>
+          <a:bodyPr/>
+          <a:lstStyle/>
+          <a:p>
+            <a:endParaRPr lang="en-IN"/>
+          </a:p>
+        </p:txBody>
       </p:sp>
       <p:sp>
         <p:nvSpPr>
@@ -3639,6 +3904,13 @@
           </a:solidFill>
           <a:ln/>
         </p:spPr>
+        <p:txBody>
+          <a:bodyPr/>
+          <a:lstStyle/>
+          <a:p>
+            <a:endParaRPr lang="en-IN"/>
+          </a:p>
+        </p:txBody>
       </p:sp>
       <p:sp>
         <p:nvSpPr>
@@ -3695,6 +3967,13 @@
           </a:solidFill>
           <a:ln/>
         </p:spPr>
+        <p:txBody>
+          <a:bodyPr/>
+          <a:lstStyle/>
+          <a:p>
+            <a:endParaRPr lang="en-IN"/>
+          </a:p>
+        </p:txBody>
       </p:sp>
       <p:sp>
         <p:nvSpPr>
@@ -3751,6 +4030,13 @@
           </a:solidFill>
           <a:ln/>
         </p:spPr>
+        <p:txBody>
+          <a:bodyPr/>
+          <a:lstStyle/>
+          <a:p>
+            <a:endParaRPr lang="en-IN"/>
+          </a:p>
+        </p:txBody>
       </p:sp>
       <p:sp>
         <p:nvSpPr>
@@ -3807,6 +4093,13 @@
           </a:solidFill>
           <a:ln/>
         </p:spPr>
+        <p:txBody>
+          <a:bodyPr/>
+          <a:lstStyle/>
+          <a:p>
+            <a:endParaRPr lang="en-IN"/>
+          </a:p>
+        </p:txBody>
       </p:sp>
       <p:sp>
         <p:nvSpPr>
@@ -3863,6 +4156,13 @@
           </a:solidFill>
           <a:ln/>
         </p:spPr>
+        <p:txBody>
+          <a:bodyPr/>
+          <a:lstStyle/>
+          <a:p>
+            <a:endParaRPr lang="en-IN"/>
+          </a:p>
+        </p:txBody>
       </p:sp>
       <p:sp>
         <p:nvSpPr>
@@ -3919,6 +4219,13 @@
           </a:solidFill>
           <a:ln/>
         </p:spPr>
+        <p:txBody>
+          <a:bodyPr/>
+          <a:lstStyle/>
+          <a:p>
+            <a:endParaRPr lang="en-IN"/>
+          </a:p>
+        </p:txBody>
       </p:sp>
       <p:sp>
         <p:nvSpPr>
@@ -3975,6 +4282,13 @@
           </a:solidFill>
           <a:ln/>
         </p:spPr>
+        <p:txBody>
+          <a:bodyPr/>
+          <a:lstStyle/>
+          <a:p>
+            <a:endParaRPr lang="en-IN"/>
+          </a:p>
+        </p:txBody>
       </p:sp>
       <p:sp>
         <p:nvSpPr>
@@ -4031,6 +4345,13 @@
           </a:solidFill>
           <a:ln/>
         </p:spPr>
+        <p:txBody>
+          <a:bodyPr/>
+          <a:lstStyle/>
+          <a:p>
+            <a:endParaRPr lang="en-IN"/>
+          </a:p>
+        </p:txBody>
       </p:sp>
       <p:sp>
         <p:nvSpPr>
@@ -4087,6 +4408,13 @@
           </a:solidFill>
           <a:ln/>
         </p:spPr>
+        <p:txBody>
+          <a:bodyPr/>
+          <a:lstStyle/>
+          <a:p>
+            <a:endParaRPr lang="en-IN"/>
+          </a:p>
+        </p:txBody>
       </p:sp>
       <p:sp>
         <p:nvSpPr>
@@ -4150,6 +4478,13 @@
             </a:outerShdw>
           </a:effectLst>
         </p:spPr>
+        <p:txBody>
+          <a:bodyPr/>
+          <a:lstStyle/>
+          <a:p>
+            <a:endParaRPr lang="en-IN"/>
+          </a:p>
+        </p:txBody>
       </p:sp>
       <p:sp>
         <p:nvSpPr>
@@ -4170,6 +4505,13 @@
           </a:solidFill>
           <a:ln/>
         </p:spPr>
+        <p:txBody>
+          <a:bodyPr/>
+          <a:lstStyle/>
+          <a:p>
+            <a:endParaRPr lang="en-IN"/>
+          </a:p>
+        </p:txBody>
       </p:sp>
       <p:sp>
         <p:nvSpPr>
@@ -4226,6 +4568,13 @@
           </a:solidFill>
           <a:ln/>
         </p:spPr>
+        <p:txBody>
+          <a:bodyPr/>
+          <a:lstStyle/>
+          <a:p>
+            <a:endParaRPr lang="en-IN"/>
+          </a:p>
+        </p:txBody>
       </p:sp>
       <p:sp>
         <p:nvSpPr>
@@ -4282,6 +4631,13 @@
           </a:solidFill>
           <a:ln/>
         </p:spPr>
+        <p:txBody>
+          <a:bodyPr/>
+          <a:lstStyle/>
+          <a:p>
+            <a:endParaRPr lang="en-IN"/>
+          </a:p>
+        </p:txBody>
       </p:sp>
       <p:sp>
         <p:nvSpPr>
@@ -4338,6 +4694,13 @@
           </a:solidFill>
           <a:ln/>
         </p:spPr>
+        <p:txBody>
+          <a:bodyPr/>
+          <a:lstStyle/>
+          <a:p>
+            <a:endParaRPr lang="en-IN"/>
+          </a:p>
+        </p:txBody>
       </p:sp>
       <p:sp>
         <p:nvSpPr>
@@ -4394,6 +4757,13 @@
           </a:solidFill>
           <a:ln/>
         </p:spPr>
+        <p:txBody>
+          <a:bodyPr/>
+          <a:lstStyle/>
+          <a:p>
+            <a:endParaRPr lang="en-IN"/>
+          </a:p>
+        </p:txBody>
       </p:sp>
       <p:sp>
         <p:nvSpPr>
@@ -4495,6 +4865,13 @@
           </a:solidFill>
           <a:ln/>
         </p:spPr>
+        <p:txBody>
+          <a:bodyPr/>
+          <a:lstStyle/>
+          <a:p>
+            <a:endParaRPr lang="en-IN"/>
+          </a:p>
+        </p:txBody>
       </p:sp>
       <p:sp>
         <p:nvSpPr>
@@ -4556,14 +4933,6 @@
             <a:pPr marL="0" indent="0">
               <a:buNone/>
             </a:pPr>
-            <a:r>
-              <a:rPr lang="en-US" sz="1000" i="1" dirty="0">
-                <a:solidFill>
-                  <a:srgbClr val="A8024F"/>
-                </a:solidFill>
-              </a:rPr>
-              <a:t>Three automated daily services managing policy health</a:t>
-            </a:r>
             <a:endParaRPr lang="en-US" sz="1000" dirty="0"/>
           </a:p>
         </p:txBody>
@@ -4587,6 +4956,13 @@
           </a:solidFill>
           <a:ln/>
         </p:spPr>
+        <p:txBody>
+          <a:bodyPr/>
+          <a:lstStyle/>
+          <a:p>
+            <a:endParaRPr lang="en-IN"/>
+          </a:p>
+        </p:txBody>
       </p:sp>
       <p:sp>
         <p:nvSpPr>
@@ -4650,6 +5026,13 @@
             </a:outerShdw>
           </a:effectLst>
         </p:spPr>
+        <p:txBody>
+          <a:bodyPr/>
+          <a:lstStyle/>
+          <a:p>
+            <a:endParaRPr lang="en-IN"/>
+          </a:p>
+        </p:txBody>
       </p:sp>
       <p:sp>
         <p:nvSpPr>
@@ -4670,6 +5053,13 @@
           </a:solidFill>
           <a:ln/>
         </p:spPr>
+        <p:txBody>
+          <a:bodyPr/>
+          <a:lstStyle/>
+          <a:p>
+            <a:endParaRPr lang="en-IN"/>
+          </a:p>
+        </p:txBody>
       </p:sp>
       <p:sp>
         <p:nvSpPr>
@@ -4762,6 +5152,13 @@
           </a:solidFill>
           <a:ln/>
         </p:spPr>
+        <p:txBody>
+          <a:bodyPr/>
+          <a:lstStyle/>
+          <a:p>
+            <a:endParaRPr lang="en-IN"/>
+          </a:p>
+        </p:txBody>
       </p:sp>
       <p:sp>
         <p:nvSpPr>
@@ -4854,6 +5251,13 @@
           </a:solidFill>
           <a:ln/>
         </p:spPr>
+        <p:txBody>
+          <a:bodyPr/>
+          <a:lstStyle/>
+          <a:p>
+            <a:endParaRPr lang="en-IN"/>
+          </a:p>
+        </p:txBody>
       </p:sp>
       <p:sp>
         <p:nvSpPr>
@@ -4946,6 +5350,13 @@
           </a:solidFill>
           <a:ln/>
         </p:spPr>
+        <p:txBody>
+          <a:bodyPr/>
+          <a:lstStyle/>
+          <a:p>
+            <a:endParaRPr lang="en-IN"/>
+          </a:p>
+        </p:txBody>
       </p:sp>
       <p:sp>
         <p:nvSpPr>
@@ -5038,6 +5449,13 @@
           </a:solidFill>
           <a:ln/>
         </p:spPr>
+        <p:txBody>
+          <a:bodyPr/>
+          <a:lstStyle/>
+          <a:p>
+            <a:endParaRPr lang="en-IN"/>
+          </a:p>
+        </p:txBody>
       </p:sp>
       <p:sp>
         <p:nvSpPr>
@@ -5137,6 +5555,13 @@
             </a:outerShdw>
           </a:effectLst>
         </p:spPr>
+        <p:txBody>
+          <a:bodyPr/>
+          <a:lstStyle/>
+          <a:p>
+            <a:endParaRPr lang="en-IN"/>
+          </a:p>
+        </p:txBody>
       </p:sp>
       <p:sp>
         <p:nvSpPr>
@@ -5157,6 +5582,13 @@
           </a:solidFill>
           <a:ln/>
         </p:spPr>
+        <p:txBody>
+          <a:bodyPr/>
+          <a:lstStyle/>
+          <a:p>
+            <a:endParaRPr lang="en-IN"/>
+          </a:p>
+        </p:txBody>
       </p:sp>
       <p:sp>
         <p:nvSpPr>
@@ -5249,6 +5681,13 @@
           </a:solidFill>
           <a:ln/>
         </p:spPr>
+        <p:txBody>
+          <a:bodyPr/>
+          <a:lstStyle/>
+          <a:p>
+            <a:endParaRPr lang="en-IN"/>
+          </a:p>
+        </p:txBody>
       </p:sp>
       <p:sp>
         <p:nvSpPr>
@@ -5341,6 +5780,13 @@
           </a:solidFill>
           <a:ln/>
         </p:spPr>
+        <p:txBody>
+          <a:bodyPr/>
+          <a:lstStyle/>
+          <a:p>
+            <a:endParaRPr lang="en-IN"/>
+          </a:p>
+        </p:txBody>
       </p:sp>
       <p:sp>
         <p:nvSpPr>
@@ -5433,6 +5879,13 @@
           </a:solidFill>
           <a:ln/>
         </p:spPr>
+        <p:txBody>
+          <a:bodyPr/>
+          <a:lstStyle/>
+          <a:p>
+            <a:endParaRPr lang="en-IN"/>
+          </a:p>
+        </p:txBody>
       </p:sp>
       <p:sp>
         <p:nvSpPr>
@@ -5525,6 +5978,13 @@
           </a:solidFill>
           <a:ln/>
         </p:spPr>
+        <p:txBody>
+          <a:bodyPr/>
+          <a:lstStyle/>
+          <a:p>
+            <a:endParaRPr lang="en-IN"/>
+          </a:p>
+        </p:txBody>
       </p:sp>
       <p:sp>
         <p:nvSpPr>
@@ -5624,6 +6084,13 @@
             </a:outerShdw>
           </a:effectLst>
         </p:spPr>
+        <p:txBody>
+          <a:bodyPr/>
+          <a:lstStyle/>
+          <a:p>
+            <a:endParaRPr lang="en-IN"/>
+          </a:p>
+        </p:txBody>
       </p:sp>
       <p:sp>
         <p:nvSpPr>
@@ -5644,6 +6111,13 @@
           </a:solidFill>
           <a:ln/>
         </p:spPr>
+        <p:txBody>
+          <a:bodyPr/>
+          <a:lstStyle/>
+          <a:p>
+            <a:endParaRPr lang="en-IN"/>
+          </a:p>
+        </p:txBody>
       </p:sp>
       <p:sp>
         <p:nvSpPr>
@@ -5736,6 +6210,13 @@
           </a:solidFill>
           <a:ln/>
         </p:spPr>
+        <p:txBody>
+          <a:bodyPr/>
+          <a:lstStyle/>
+          <a:p>
+            <a:endParaRPr lang="en-IN"/>
+          </a:p>
+        </p:txBody>
       </p:sp>
       <p:sp>
         <p:nvSpPr>
@@ -5828,6 +6309,13 @@
           </a:solidFill>
           <a:ln/>
         </p:spPr>
+        <p:txBody>
+          <a:bodyPr/>
+          <a:lstStyle/>
+          <a:p>
+            <a:endParaRPr lang="en-IN"/>
+          </a:p>
+        </p:txBody>
       </p:sp>
       <p:sp>
         <p:nvSpPr>
@@ -5920,6 +6408,13 @@
           </a:solidFill>
           <a:ln/>
         </p:spPr>
+        <p:txBody>
+          <a:bodyPr/>
+          <a:lstStyle/>
+          <a:p>
+            <a:endParaRPr lang="en-IN"/>
+          </a:p>
+        </p:txBody>
       </p:sp>
       <p:sp>
         <p:nvSpPr>
@@ -6012,6 +6507,13 @@
           </a:solidFill>
           <a:ln/>
         </p:spPr>
+        <p:txBody>
+          <a:bodyPr/>
+          <a:lstStyle/>
+          <a:p>
+            <a:endParaRPr lang="en-IN"/>
+          </a:p>
+        </p:txBody>
       </p:sp>
       <p:sp>
         <p:nvSpPr>
@@ -6104,6 +6606,13 @@
           </a:solidFill>
           <a:ln/>
         </p:spPr>
+        <p:txBody>
+          <a:bodyPr/>
+          <a:lstStyle/>
+          <a:p>
+            <a:endParaRPr lang="en-IN"/>
+          </a:p>
+        </p:txBody>
       </p:sp>
       <p:sp>
         <p:nvSpPr>
@@ -6205,6 +6714,13 @@
           </a:solidFill>
           <a:ln/>
         </p:spPr>
+        <p:txBody>
+          <a:bodyPr/>
+          <a:lstStyle/>
+          <a:p>
+            <a:endParaRPr lang="en-IN"/>
+          </a:p>
+        </p:txBody>
       </p:sp>
       <p:sp>
         <p:nvSpPr>
@@ -6289,6 +6805,13 @@
           </a:solidFill>
           <a:ln/>
         </p:spPr>
+        <p:txBody>
+          <a:bodyPr/>
+          <a:lstStyle/>
+          <a:p>
+            <a:endParaRPr lang="en-IN"/>
+          </a:p>
+        </p:txBody>
       </p:sp>
       <p:sp>
         <p:nvSpPr>
@@ -6352,6 +6875,13 @@
             </a:outerShdw>
           </a:effectLst>
         </p:spPr>
+        <p:txBody>
+          <a:bodyPr/>
+          <a:lstStyle/>
+          <a:p>
+            <a:endParaRPr lang="en-IN"/>
+          </a:p>
+        </p:txBody>
       </p:sp>
       <p:sp>
         <p:nvSpPr>
@@ -6372,6 +6902,13 @@
           </a:solidFill>
           <a:ln/>
         </p:spPr>
+        <p:txBody>
+          <a:bodyPr/>
+          <a:lstStyle/>
+          <a:p>
+            <a:endParaRPr lang="en-IN"/>
+          </a:p>
+        </p:txBody>
       </p:sp>
       <p:sp>
         <p:nvSpPr>
@@ -6471,6 +7008,13 @@
             </a:outerShdw>
           </a:effectLst>
         </p:spPr>
+        <p:txBody>
+          <a:bodyPr/>
+          <a:lstStyle/>
+          <a:p>
+            <a:endParaRPr lang="en-IN"/>
+          </a:p>
+        </p:txBody>
       </p:sp>
       <p:sp>
         <p:nvSpPr>
@@ -6491,6 +7035,13 @@
           </a:solidFill>
           <a:ln/>
         </p:spPr>
+        <p:txBody>
+          <a:bodyPr/>
+          <a:lstStyle/>
+          <a:p>
+            <a:endParaRPr lang="en-IN"/>
+          </a:p>
+        </p:txBody>
       </p:sp>
       <p:sp>
         <p:nvSpPr>
@@ -6590,6 +7141,13 @@
             </a:outerShdw>
           </a:effectLst>
         </p:spPr>
+        <p:txBody>
+          <a:bodyPr/>
+          <a:lstStyle/>
+          <a:p>
+            <a:endParaRPr lang="en-IN"/>
+          </a:p>
+        </p:txBody>
       </p:sp>
       <p:sp>
         <p:nvSpPr>
@@ -6610,6 +7168,13 @@
           </a:solidFill>
           <a:ln/>
         </p:spPr>
+        <p:txBody>
+          <a:bodyPr/>
+          <a:lstStyle/>
+          <a:p>
+            <a:endParaRPr lang="en-IN"/>
+          </a:p>
+        </p:txBody>
       </p:sp>
       <p:sp>
         <p:nvSpPr>
@@ -6709,6 +7274,13 @@
             </a:outerShdw>
           </a:effectLst>
         </p:spPr>
+        <p:txBody>
+          <a:bodyPr/>
+          <a:lstStyle/>
+          <a:p>
+            <a:endParaRPr lang="en-IN"/>
+          </a:p>
+        </p:txBody>
       </p:sp>
       <p:sp>
         <p:nvSpPr>
@@ -6729,6 +7301,13 @@
           </a:solidFill>
           <a:ln/>
         </p:spPr>
+        <p:txBody>
+          <a:bodyPr/>
+          <a:lstStyle/>
+          <a:p>
+            <a:endParaRPr lang="en-IN"/>
+          </a:p>
+        </p:txBody>
       </p:sp>
       <p:sp>
         <p:nvSpPr>
@@ -6828,6 +7407,13 @@
             </a:outerShdw>
           </a:effectLst>
         </p:spPr>
+        <p:txBody>
+          <a:bodyPr/>
+          <a:lstStyle/>
+          <a:p>
+            <a:endParaRPr lang="en-IN"/>
+          </a:p>
+        </p:txBody>
       </p:sp>
       <p:sp>
         <p:nvSpPr>
@@ -6848,6 +7434,13 @@
           </a:solidFill>
           <a:ln/>
         </p:spPr>
+        <p:txBody>
+          <a:bodyPr/>
+          <a:lstStyle/>
+          <a:p>
+            <a:endParaRPr lang="en-IN"/>
+          </a:p>
+        </p:txBody>
       </p:sp>
       <p:sp>
         <p:nvSpPr>
@@ -6947,6 +7540,13 @@
             </a:outerShdw>
           </a:effectLst>
         </p:spPr>
+        <p:txBody>
+          <a:bodyPr/>
+          <a:lstStyle/>
+          <a:p>
+            <a:endParaRPr lang="en-IN"/>
+          </a:p>
+        </p:txBody>
       </p:sp>
       <p:sp>
         <p:nvSpPr>
@@ -6967,6 +7567,13 @@
           </a:solidFill>
           <a:ln/>
         </p:spPr>
+        <p:txBody>
+          <a:bodyPr/>
+          <a:lstStyle/>
+          <a:p>
+            <a:endParaRPr lang="en-IN"/>
+          </a:p>
+        </p:txBody>
       </p:sp>
       <p:sp>
         <p:nvSpPr>
@@ -7066,6 +7673,13 @@
             </a:outerShdw>
           </a:effectLst>
         </p:spPr>
+        <p:txBody>
+          <a:bodyPr/>
+          <a:lstStyle/>
+          <a:p>
+            <a:endParaRPr lang="en-IN"/>
+          </a:p>
+        </p:txBody>
       </p:sp>
       <p:sp>
         <p:nvSpPr>
@@ -7086,6 +7700,13 @@
           </a:solidFill>
           <a:ln/>
         </p:spPr>
+        <p:txBody>
+          <a:bodyPr/>
+          <a:lstStyle/>
+          <a:p>
+            <a:endParaRPr lang="en-IN"/>
+          </a:p>
+        </p:txBody>
       </p:sp>
       <p:sp>
         <p:nvSpPr>
@@ -7185,6 +7806,13 @@
             </a:outerShdw>
           </a:effectLst>
         </p:spPr>
+        <p:txBody>
+          <a:bodyPr/>
+          <a:lstStyle/>
+          <a:p>
+            <a:endParaRPr lang="en-IN"/>
+          </a:p>
+        </p:txBody>
       </p:sp>
       <p:sp>
         <p:nvSpPr>
@@ -7205,6 +7833,13 @@
           </a:solidFill>
           <a:ln/>
         </p:spPr>
+        <p:txBody>
+          <a:bodyPr/>
+          <a:lstStyle/>
+          <a:p>
+            <a:endParaRPr lang="en-IN"/>
+          </a:p>
+        </p:txBody>
       </p:sp>
       <p:sp>
         <p:nvSpPr>
@@ -7304,6 +7939,13 @@
             </a:outerShdw>
           </a:effectLst>
         </p:spPr>
+        <p:txBody>
+          <a:bodyPr/>
+          <a:lstStyle/>
+          <a:p>
+            <a:endParaRPr lang="en-IN"/>
+          </a:p>
+        </p:txBody>
       </p:sp>
       <p:sp>
         <p:nvSpPr>
@@ -7324,6 +7966,13 @@
           </a:solidFill>
           <a:ln/>
         </p:spPr>
+        <p:txBody>
+          <a:bodyPr/>
+          <a:lstStyle/>
+          <a:p>
+            <a:endParaRPr lang="en-IN"/>
+          </a:p>
+        </p:txBody>
       </p:sp>
       <p:sp>
         <p:nvSpPr>
@@ -7423,6 +8072,13 @@
             </a:outerShdw>
           </a:effectLst>
         </p:spPr>
+        <p:txBody>
+          <a:bodyPr/>
+          <a:lstStyle/>
+          <a:p>
+            <a:endParaRPr lang="en-IN"/>
+          </a:p>
+        </p:txBody>
       </p:sp>
       <p:sp>
         <p:nvSpPr>
@@ -7443,6 +8099,13 @@
           </a:solidFill>
           <a:ln/>
         </p:spPr>
+        <p:txBody>
+          <a:bodyPr/>
+          <a:lstStyle/>
+          <a:p>
+            <a:endParaRPr lang="en-IN"/>
+          </a:p>
+        </p:txBody>
       </p:sp>
       <p:sp>
         <p:nvSpPr>
@@ -7585,6 +8248,13 @@
             <a:prstDash val="solid"/>
           </a:ln>
         </p:spPr>
+        <p:txBody>
+          <a:bodyPr/>
+          <a:lstStyle/>
+          <a:p>
+            <a:endParaRPr lang="en-IN"/>
+          </a:p>
+        </p:txBody>
       </p:sp>
       <p:sp>
         <p:nvSpPr>
@@ -7610,6 +8280,13 @@
             <a:prstDash val="solid"/>
           </a:ln>
         </p:spPr>
+        <p:txBody>
+          <a:bodyPr/>
+          <a:lstStyle/>
+          <a:p>
+            <a:endParaRPr lang="en-IN"/>
+          </a:p>
+        </p:txBody>
       </p:sp>
       <p:sp>
         <p:nvSpPr>
@@ -7630,6 +8307,13 @@
           </a:solidFill>
           <a:ln/>
         </p:spPr>
+        <p:txBody>
+          <a:bodyPr/>
+          <a:lstStyle/>
+          <a:p>
+            <a:endParaRPr lang="en-IN"/>
+          </a:p>
+        </p:txBody>
       </p:sp>
       <p:sp>
         <p:nvSpPr>
@@ -7715,23 +8399,7 @@
                   <a:schemeClr val="bg1"/>
                 </a:solidFill>
               </a:rPr>
-              <a:t>Mr. Surya </a:t>
-            </a:r>
-            <a:r>
-              <a:rPr lang="en-US" sz="1600" b="1" dirty="0" err="1">
-                <a:solidFill>
-                  <a:schemeClr val="bg1"/>
-                </a:solidFill>
-              </a:rPr>
-              <a:t>Thammiraju</a:t>
-            </a:r>
-            <a:r>
-              <a:rPr lang="en-US" sz="1600" b="1" dirty="0">
-                <a:solidFill>
-                  <a:schemeClr val="bg1"/>
-                </a:solidFill>
-              </a:rPr>
-              <a:t> </a:t>
+              <a:t>Mr. Surya Thammiraju </a:t>
             </a:r>
             <a:r>
               <a:rPr lang="en-US" sz="1600" dirty="0">
@@ -7879,6 +8547,13 @@
           </a:solidFill>
           <a:ln/>
         </p:spPr>
+        <p:txBody>
+          <a:bodyPr/>
+          <a:lstStyle/>
+          <a:p>
+            <a:endParaRPr lang="en-IN"/>
+          </a:p>
+        </p:txBody>
       </p:sp>
       <p:sp>
         <p:nvSpPr>
@@ -7940,14 +8615,6 @@
             <a:pPr marL="0" indent="0">
               <a:buNone/>
             </a:pPr>
-            <a:r>
-              <a:rPr lang="en-US" sz="1000" i="1" dirty="0">
-                <a:solidFill>
-                  <a:srgbClr val="A8024F"/>
-                </a:solidFill>
-              </a:rPr>
-              <a:t>Why a new insurance management system is needed</a:t>
-            </a:r>
             <a:endParaRPr lang="en-US" sz="1000" dirty="0"/>
           </a:p>
         </p:txBody>
@@ -8041,6 +8708,13 @@
             </a:outerShdw>
           </a:effectLst>
         </p:spPr>
+        <p:txBody>
+          <a:bodyPr/>
+          <a:lstStyle/>
+          <a:p>
+            <a:endParaRPr lang="en-IN"/>
+          </a:p>
+        </p:txBody>
       </p:sp>
       <p:sp>
         <p:nvSpPr>
@@ -8061,6 +8735,13 @@
           </a:solidFill>
           <a:ln/>
         </p:spPr>
+        <p:txBody>
+          <a:bodyPr/>
+          <a:lstStyle/>
+          <a:p>
+            <a:endParaRPr lang="en-IN"/>
+          </a:p>
+        </p:txBody>
       </p:sp>
       <p:sp>
         <p:nvSpPr>
@@ -8163,6 +8844,13 @@
           </a:solidFill>
           <a:ln/>
         </p:spPr>
+        <p:txBody>
+          <a:bodyPr/>
+          <a:lstStyle/>
+          <a:p>
+            <a:endParaRPr lang="en-IN"/>
+          </a:p>
+        </p:txBody>
       </p:sp>
       <p:sp>
         <p:nvSpPr>
@@ -8219,6 +8907,13 @@
           </a:solidFill>
           <a:ln/>
         </p:spPr>
+        <p:txBody>
+          <a:bodyPr/>
+          <a:lstStyle/>
+          <a:p>
+            <a:endParaRPr lang="en-IN"/>
+          </a:p>
+        </p:txBody>
       </p:sp>
       <p:sp>
         <p:nvSpPr>
@@ -8275,6 +8970,13 @@
           </a:solidFill>
           <a:ln/>
         </p:spPr>
+        <p:txBody>
+          <a:bodyPr/>
+          <a:lstStyle/>
+          <a:p>
+            <a:endParaRPr lang="en-IN"/>
+          </a:p>
+        </p:txBody>
       </p:sp>
       <p:sp>
         <p:nvSpPr>
@@ -8331,6 +9033,13 @@
           </a:solidFill>
           <a:ln/>
         </p:spPr>
+        <p:txBody>
+          <a:bodyPr/>
+          <a:lstStyle/>
+          <a:p>
+            <a:endParaRPr lang="en-IN"/>
+          </a:p>
+        </p:txBody>
       </p:sp>
       <p:sp>
         <p:nvSpPr>
@@ -8394,6 +9103,13 @@
             </a:outerShdw>
           </a:effectLst>
         </p:spPr>
+        <p:txBody>
+          <a:bodyPr/>
+          <a:lstStyle/>
+          <a:p>
+            <a:endParaRPr lang="en-IN"/>
+          </a:p>
+        </p:txBody>
       </p:sp>
       <p:sp>
         <p:nvSpPr>
@@ -8486,6 +9202,13 @@
           </a:solidFill>
           <a:ln/>
         </p:spPr>
+        <p:txBody>
+          <a:bodyPr/>
+          <a:lstStyle/>
+          <a:p>
+            <a:endParaRPr lang="en-IN"/>
+          </a:p>
+        </p:txBody>
       </p:sp>
       <p:sp>
         <p:nvSpPr>
@@ -8578,6 +9301,13 @@
           </a:solidFill>
           <a:ln/>
         </p:spPr>
+        <p:txBody>
+          <a:bodyPr/>
+          <a:lstStyle/>
+          <a:p>
+            <a:endParaRPr lang="en-IN"/>
+          </a:p>
+        </p:txBody>
       </p:sp>
       <p:sp>
         <p:nvSpPr>
@@ -8670,6 +9400,13 @@
           </a:solidFill>
           <a:ln/>
         </p:spPr>
+        <p:txBody>
+          <a:bodyPr/>
+          <a:lstStyle/>
+          <a:p>
+            <a:endParaRPr lang="en-IN"/>
+          </a:p>
+        </p:txBody>
       </p:sp>
       <p:sp>
         <p:nvSpPr>
@@ -8807,6 +9544,13 @@
           </a:solidFill>
           <a:ln/>
         </p:spPr>
+        <p:txBody>
+          <a:bodyPr/>
+          <a:lstStyle/>
+          <a:p>
+            <a:endParaRPr lang="en-IN"/>
+          </a:p>
+        </p:txBody>
       </p:sp>
       <p:sp>
         <p:nvSpPr>
@@ -8899,6 +9643,13 @@
           </a:solidFill>
           <a:ln/>
         </p:spPr>
+        <p:txBody>
+          <a:bodyPr/>
+          <a:lstStyle/>
+          <a:p>
+            <a:endParaRPr lang="en-IN"/>
+          </a:p>
+        </p:txBody>
       </p:sp>
       <p:sp>
         <p:nvSpPr>
@@ -8962,6 +9713,13 @@
             </a:outerShdw>
           </a:effectLst>
         </p:spPr>
+        <p:txBody>
+          <a:bodyPr/>
+          <a:lstStyle/>
+          <a:p>
+            <a:endParaRPr lang="en-IN"/>
+          </a:p>
+        </p:txBody>
       </p:sp>
       <p:sp>
         <p:nvSpPr>
@@ -9054,6 +9812,13 @@
           </a:solidFill>
           <a:ln/>
         </p:spPr>
+        <p:txBody>
+          <a:bodyPr/>
+          <a:lstStyle/>
+          <a:p>
+            <a:endParaRPr lang="en-IN"/>
+          </a:p>
+        </p:txBody>
       </p:sp>
       <p:sp>
         <p:nvSpPr>
@@ -9081,6 +9846,13 @@
             </a:outerShdw>
           </a:effectLst>
         </p:spPr>
+        <p:txBody>
+          <a:bodyPr/>
+          <a:lstStyle/>
+          <a:p>
+            <a:endParaRPr lang="en-IN"/>
+          </a:p>
+        </p:txBody>
       </p:sp>
       <p:sp>
         <p:nvSpPr>
@@ -9173,6 +9945,13 @@
           </a:solidFill>
           <a:ln/>
         </p:spPr>
+        <p:txBody>
+          <a:bodyPr/>
+          <a:lstStyle/>
+          <a:p>
+            <a:endParaRPr lang="en-IN"/>
+          </a:p>
+        </p:txBody>
       </p:sp>
       <p:sp>
         <p:nvSpPr>
@@ -9200,6 +9979,13 @@
             </a:outerShdw>
           </a:effectLst>
         </p:spPr>
+        <p:txBody>
+          <a:bodyPr/>
+          <a:lstStyle/>
+          <a:p>
+            <a:endParaRPr lang="en-IN"/>
+          </a:p>
+        </p:txBody>
       </p:sp>
       <p:sp>
         <p:nvSpPr>
@@ -9292,6 +10078,13 @@
           </a:solidFill>
           <a:ln/>
         </p:spPr>
+        <p:txBody>
+          <a:bodyPr/>
+          <a:lstStyle/>
+          <a:p>
+            <a:endParaRPr lang="en-IN"/>
+          </a:p>
+        </p:txBody>
       </p:sp>
       <p:sp>
         <p:nvSpPr>
@@ -9319,6 +10112,13 @@
             </a:outerShdw>
           </a:effectLst>
         </p:spPr>
+        <p:txBody>
+          <a:bodyPr/>
+          <a:lstStyle/>
+          <a:p>
+            <a:endParaRPr lang="en-IN"/>
+          </a:p>
+        </p:txBody>
       </p:sp>
       <p:sp>
         <p:nvSpPr>
@@ -9411,6 +10211,13 @@
           </a:solidFill>
           <a:ln/>
         </p:spPr>
+        <p:txBody>
+          <a:bodyPr/>
+          <a:lstStyle/>
+          <a:p>
+            <a:endParaRPr lang="en-IN"/>
+          </a:p>
+        </p:txBody>
       </p:sp>
       <p:sp>
         <p:nvSpPr>
@@ -9438,6 +10245,13 @@
             </a:outerShdw>
           </a:effectLst>
         </p:spPr>
+        <p:txBody>
+          <a:bodyPr/>
+          <a:lstStyle/>
+          <a:p>
+            <a:endParaRPr lang="en-IN"/>
+          </a:p>
+        </p:txBody>
       </p:sp>
       <p:sp>
         <p:nvSpPr>
@@ -9573,6 +10387,13 @@
             </a:outerShdw>
           </a:effectLst>
         </p:spPr>
+        <p:txBody>
+          <a:bodyPr/>
+          <a:lstStyle/>
+          <a:p>
+            <a:endParaRPr lang="en-IN"/>
+          </a:p>
+        </p:txBody>
       </p:sp>
       <p:sp>
         <p:nvSpPr>
@@ -9636,6 +10457,13 @@
             </a:outerShdw>
           </a:effectLst>
         </p:spPr>
+        <p:txBody>
+          <a:bodyPr/>
+          <a:lstStyle/>
+          <a:p>
+            <a:endParaRPr lang="en-IN"/>
+          </a:p>
+        </p:txBody>
       </p:sp>
       <p:sp>
         <p:nvSpPr>
@@ -9699,6 +10527,13 @@
             </a:outerShdw>
           </a:effectLst>
         </p:spPr>
+        <p:txBody>
+          <a:bodyPr/>
+          <a:lstStyle/>
+          <a:p>
+            <a:endParaRPr lang="en-IN"/>
+          </a:p>
+        </p:txBody>
       </p:sp>
       <p:sp>
         <p:nvSpPr>
@@ -9762,6 +10597,13 @@
             </a:outerShdw>
           </a:effectLst>
         </p:spPr>
+        <p:txBody>
+          <a:bodyPr/>
+          <a:lstStyle/>
+          <a:p>
+            <a:endParaRPr lang="en-IN"/>
+          </a:p>
+        </p:txBody>
       </p:sp>
       <p:sp>
         <p:nvSpPr>
@@ -9863,6 +10705,13 @@
           </a:solidFill>
           <a:ln/>
         </p:spPr>
+        <p:txBody>
+          <a:bodyPr/>
+          <a:lstStyle/>
+          <a:p>
+            <a:endParaRPr lang="en-IN"/>
+          </a:p>
+        </p:txBody>
       </p:sp>
       <p:sp>
         <p:nvSpPr>
@@ -9924,14 +10773,6 @@
             <a:pPr marL="0" indent="0">
               <a:buNone/>
             </a:pPr>
-            <a:r>
-              <a:rPr lang="en-US" sz="1000" i="1" dirty="0">
-                <a:solidFill>
-                  <a:srgbClr val="A8024F"/>
-                </a:solidFill>
-              </a:rPr>
-              <a:t>8 integrated modules covering the complete insurance lifecycle</a:t>
-            </a:r>
             <a:endParaRPr lang="en-US" sz="1000" dirty="0"/>
           </a:p>
         </p:txBody>
@@ -9955,6 +10796,13 @@
           </a:solidFill>
           <a:ln/>
         </p:spPr>
+        <p:txBody>
+          <a:bodyPr/>
+          <a:lstStyle/>
+          <a:p>
+            <a:endParaRPr lang="en-IN"/>
+          </a:p>
+        </p:txBody>
       </p:sp>
       <p:sp>
         <p:nvSpPr>
@@ -10018,6 +10866,13 @@
             </a:outerShdw>
           </a:effectLst>
         </p:spPr>
+        <p:txBody>
+          <a:bodyPr/>
+          <a:lstStyle/>
+          <a:p>
+            <a:endParaRPr lang="en-IN"/>
+          </a:p>
+        </p:txBody>
       </p:sp>
       <p:sp>
         <p:nvSpPr>
@@ -10038,6 +10893,13 @@
           </a:solidFill>
           <a:ln/>
         </p:spPr>
+        <p:txBody>
+          <a:bodyPr/>
+          <a:lstStyle/>
+          <a:p>
+            <a:endParaRPr lang="en-IN"/>
+          </a:p>
+        </p:txBody>
       </p:sp>
       <p:sp>
         <p:nvSpPr>
@@ -10058,6 +10920,13 @@
           </a:solidFill>
           <a:ln/>
         </p:spPr>
+        <p:txBody>
+          <a:bodyPr/>
+          <a:lstStyle/>
+          <a:p>
+            <a:endParaRPr lang="en-IN"/>
+          </a:p>
+        </p:txBody>
       </p:sp>
       <p:pic>
         <p:nvPicPr>
@@ -10181,6 +11050,13 @@
             </a:outerShdw>
           </a:effectLst>
         </p:spPr>
+        <p:txBody>
+          <a:bodyPr/>
+          <a:lstStyle/>
+          <a:p>
+            <a:endParaRPr lang="en-IN"/>
+          </a:p>
+        </p:txBody>
       </p:sp>
       <p:sp>
         <p:nvSpPr>
@@ -10201,6 +11077,13 @@
           </a:solidFill>
           <a:ln/>
         </p:spPr>
+        <p:txBody>
+          <a:bodyPr/>
+          <a:lstStyle/>
+          <a:p>
+            <a:endParaRPr lang="en-IN"/>
+          </a:p>
+        </p:txBody>
       </p:sp>
       <p:sp>
         <p:nvSpPr>
@@ -10221,6 +11104,13 @@
           </a:solidFill>
           <a:ln/>
         </p:spPr>
+        <p:txBody>
+          <a:bodyPr/>
+          <a:lstStyle/>
+          <a:p>
+            <a:endParaRPr lang="en-IN"/>
+          </a:p>
+        </p:txBody>
       </p:sp>
       <p:pic>
         <p:nvPicPr>
@@ -10344,6 +11234,13 @@
             </a:outerShdw>
           </a:effectLst>
         </p:spPr>
+        <p:txBody>
+          <a:bodyPr/>
+          <a:lstStyle/>
+          <a:p>
+            <a:endParaRPr lang="en-IN"/>
+          </a:p>
+        </p:txBody>
       </p:sp>
       <p:sp>
         <p:nvSpPr>
@@ -10364,6 +11261,13 @@
           </a:solidFill>
           <a:ln/>
         </p:spPr>
+        <p:txBody>
+          <a:bodyPr/>
+          <a:lstStyle/>
+          <a:p>
+            <a:endParaRPr lang="en-IN"/>
+          </a:p>
+        </p:txBody>
       </p:sp>
       <p:sp>
         <p:nvSpPr>
@@ -10384,6 +11288,13 @@
           </a:solidFill>
           <a:ln/>
         </p:spPr>
+        <p:txBody>
+          <a:bodyPr/>
+          <a:lstStyle/>
+          <a:p>
+            <a:endParaRPr lang="en-IN"/>
+          </a:p>
+        </p:txBody>
       </p:sp>
       <p:pic>
         <p:nvPicPr>
@@ -10507,6 +11418,13 @@
             </a:outerShdw>
           </a:effectLst>
         </p:spPr>
+        <p:txBody>
+          <a:bodyPr/>
+          <a:lstStyle/>
+          <a:p>
+            <a:endParaRPr lang="en-IN"/>
+          </a:p>
+        </p:txBody>
       </p:sp>
       <p:sp>
         <p:nvSpPr>
@@ -10527,6 +11445,13 @@
           </a:solidFill>
           <a:ln/>
         </p:spPr>
+        <p:txBody>
+          <a:bodyPr/>
+          <a:lstStyle/>
+          <a:p>
+            <a:endParaRPr lang="en-IN"/>
+          </a:p>
+        </p:txBody>
       </p:sp>
       <p:sp>
         <p:nvSpPr>
@@ -10547,6 +11472,13 @@
           </a:solidFill>
           <a:ln/>
         </p:spPr>
+        <p:txBody>
+          <a:bodyPr/>
+          <a:lstStyle/>
+          <a:p>
+            <a:endParaRPr lang="en-IN"/>
+          </a:p>
+        </p:txBody>
       </p:sp>
       <p:pic>
         <p:nvPicPr>
@@ -10670,6 +11602,13 @@
             </a:outerShdw>
           </a:effectLst>
         </p:spPr>
+        <p:txBody>
+          <a:bodyPr/>
+          <a:lstStyle/>
+          <a:p>
+            <a:endParaRPr lang="en-IN"/>
+          </a:p>
+        </p:txBody>
       </p:sp>
       <p:sp>
         <p:nvSpPr>
@@ -10690,6 +11629,13 @@
           </a:solidFill>
           <a:ln/>
         </p:spPr>
+        <p:txBody>
+          <a:bodyPr/>
+          <a:lstStyle/>
+          <a:p>
+            <a:endParaRPr lang="en-IN"/>
+          </a:p>
+        </p:txBody>
       </p:sp>
       <p:sp>
         <p:nvSpPr>
@@ -10710,6 +11656,13 @@
           </a:solidFill>
           <a:ln/>
         </p:spPr>
+        <p:txBody>
+          <a:bodyPr/>
+          <a:lstStyle/>
+          <a:p>
+            <a:endParaRPr lang="en-IN"/>
+          </a:p>
+        </p:txBody>
       </p:sp>
       <p:pic>
         <p:nvPicPr>
@@ -10833,6 +11786,13 @@
             </a:outerShdw>
           </a:effectLst>
         </p:spPr>
+        <p:txBody>
+          <a:bodyPr/>
+          <a:lstStyle/>
+          <a:p>
+            <a:endParaRPr lang="en-IN"/>
+          </a:p>
+        </p:txBody>
       </p:sp>
       <p:sp>
         <p:nvSpPr>
@@ -10853,6 +11813,13 @@
           </a:solidFill>
           <a:ln/>
         </p:spPr>
+        <p:txBody>
+          <a:bodyPr/>
+          <a:lstStyle/>
+          <a:p>
+            <a:endParaRPr lang="en-IN"/>
+          </a:p>
+        </p:txBody>
       </p:sp>
       <p:sp>
         <p:nvSpPr>
@@ -10873,6 +11840,13 @@
           </a:solidFill>
           <a:ln/>
         </p:spPr>
+        <p:txBody>
+          <a:bodyPr/>
+          <a:lstStyle/>
+          <a:p>
+            <a:endParaRPr lang="en-IN"/>
+          </a:p>
+        </p:txBody>
       </p:sp>
       <p:pic>
         <p:nvPicPr>
@@ -10996,6 +11970,13 @@
             </a:outerShdw>
           </a:effectLst>
         </p:spPr>
+        <p:txBody>
+          <a:bodyPr/>
+          <a:lstStyle/>
+          <a:p>
+            <a:endParaRPr lang="en-IN"/>
+          </a:p>
+        </p:txBody>
       </p:sp>
       <p:sp>
         <p:nvSpPr>
@@ -11016,6 +11997,13 @@
           </a:solidFill>
           <a:ln/>
         </p:spPr>
+        <p:txBody>
+          <a:bodyPr/>
+          <a:lstStyle/>
+          <a:p>
+            <a:endParaRPr lang="en-IN"/>
+          </a:p>
+        </p:txBody>
       </p:sp>
       <p:sp>
         <p:nvSpPr>
@@ -11036,6 +12024,13 @@
           </a:solidFill>
           <a:ln/>
         </p:spPr>
+        <p:txBody>
+          <a:bodyPr/>
+          <a:lstStyle/>
+          <a:p>
+            <a:endParaRPr lang="en-IN"/>
+          </a:p>
+        </p:txBody>
       </p:sp>
       <p:pic>
         <p:nvPicPr>
@@ -11159,6 +12154,13 @@
             </a:outerShdw>
           </a:effectLst>
         </p:spPr>
+        <p:txBody>
+          <a:bodyPr/>
+          <a:lstStyle/>
+          <a:p>
+            <a:endParaRPr lang="en-IN"/>
+          </a:p>
+        </p:txBody>
       </p:sp>
       <p:sp>
         <p:nvSpPr>
@@ -11179,6 +12181,13 @@
           </a:solidFill>
           <a:ln/>
         </p:spPr>
+        <p:txBody>
+          <a:bodyPr/>
+          <a:lstStyle/>
+          <a:p>
+            <a:endParaRPr lang="en-IN"/>
+          </a:p>
+        </p:txBody>
       </p:sp>
       <p:sp>
         <p:nvSpPr>
@@ -11199,6 +12208,13 @@
           </a:solidFill>
           <a:ln/>
         </p:spPr>
+        <p:txBody>
+          <a:bodyPr/>
+          <a:lstStyle/>
+          <a:p>
+            <a:endParaRPr lang="en-IN"/>
+          </a:p>
+        </p:txBody>
       </p:sp>
       <p:pic>
         <p:nvPicPr>
@@ -11360,6 +12376,13 @@
           </a:solidFill>
           <a:ln/>
         </p:spPr>
+        <p:txBody>
+          <a:bodyPr/>
+          <a:lstStyle/>
+          <a:p>
+            <a:endParaRPr lang="en-IN"/>
+          </a:p>
+        </p:txBody>
       </p:sp>
       <p:sp>
         <p:nvSpPr>
@@ -11421,14 +12444,6 @@
             <a:pPr marL="0" indent="0">
               <a:buNone/>
             </a:pPr>
-            <a:r>
-              <a:rPr lang="en-US" sz="1000" i="1" dirty="0">
-                <a:solidFill>
-                  <a:srgbClr val="A8024F"/>
-                </a:solidFill>
-              </a:rPr>
-              <a:t>Secure multi-role access with JWT and CAPTCHA</a:t>
-            </a:r>
             <a:endParaRPr lang="en-US" sz="1000" dirty="0"/>
           </a:p>
         </p:txBody>
@@ -11452,6 +12467,13 @@
           </a:solidFill>
           <a:ln/>
         </p:spPr>
+        <p:txBody>
+          <a:bodyPr/>
+          <a:lstStyle/>
+          <a:p>
+            <a:endParaRPr lang="en-IN"/>
+          </a:p>
+        </p:txBody>
       </p:sp>
       <p:sp>
         <p:nvSpPr>
@@ -11515,6 +12537,13 @@
             </a:outerShdw>
           </a:effectLst>
         </p:spPr>
+        <p:txBody>
+          <a:bodyPr/>
+          <a:lstStyle/>
+          <a:p>
+            <a:endParaRPr lang="en-IN"/>
+          </a:p>
+        </p:txBody>
       </p:sp>
       <p:sp>
         <p:nvSpPr>
@@ -11650,6 +12679,13 @@
             </a:outerShdw>
           </a:effectLst>
         </p:spPr>
+        <p:txBody>
+          <a:bodyPr/>
+          <a:lstStyle/>
+          <a:p>
+            <a:endParaRPr lang="en-IN"/>
+          </a:p>
+        </p:txBody>
       </p:sp>
       <p:sp>
         <p:nvSpPr>
@@ -11785,6 +12821,13 @@
             </a:outerShdw>
           </a:effectLst>
         </p:spPr>
+        <p:txBody>
+          <a:bodyPr/>
+          <a:lstStyle/>
+          <a:p>
+            <a:endParaRPr lang="en-IN"/>
+          </a:p>
+        </p:txBody>
       </p:sp>
       <p:sp>
         <p:nvSpPr>
@@ -11920,6 +12963,13 @@
             </a:outerShdw>
           </a:effectLst>
         </p:spPr>
+        <p:txBody>
+          <a:bodyPr/>
+          <a:lstStyle/>
+          <a:p>
+            <a:endParaRPr lang="en-IN"/>
+          </a:p>
+        </p:txBody>
       </p:sp>
       <p:sp>
         <p:nvSpPr>
@@ -12055,6 +13105,13 @@
             </a:outerShdw>
           </a:effectLst>
         </p:spPr>
+        <p:txBody>
+          <a:bodyPr/>
+          <a:lstStyle/>
+          <a:p>
+            <a:endParaRPr lang="en-IN"/>
+          </a:p>
+        </p:txBody>
       </p:sp>
       <p:sp>
         <p:nvSpPr>
@@ -12190,6 +13247,13 @@
             </a:outerShdw>
           </a:effectLst>
         </p:spPr>
+        <p:txBody>
+          <a:bodyPr/>
+          <a:lstStyle/>
+          <a:p>
+            <a:endParaRPr lang="en-IN"/>
+          </a:p>
+        </p:txBody>
       </p:sp>
       <p:sp>
         <p:nvSpPr>
@@ -12210,6 +13274,13 @@
           </a:solidFill>
           <a:ln/>
         </p:spPr>
+        <p:txBody>
+          <a:bodyPr/>
+          <a:lstStyle/>
+          <a:p>
+            <a:endParaRPr lang="en-IN"/>
+          </a:p>
+        </p:txBody>
       </p:sp>
       <p:sp>
         <p:nvSpPr>
@@ -12306,6 +13377,13 @@
             </a:outerShdw>
           </a:effectLst>
         </p:spPr>
+        <p:txBody>
+          <a:bodyPr/>
+          <a:lstStyle/>
+          <a:p>
+            <a:endParaRPr lang="en-IN"/>
+          </a:p>
+        </p:txBody>
       </p:sp>
       <p:sp>
         <p:nvSpPr>
@@ -12326,6 +13404,13 @@
           </a:solidFill>
           <a:ln/>
         </p:spPr>
+        <p:txBody>
+          <a:bodyPr/>
+          <a:lstStyle/>
+          <a:p>
+            <a:endParaRPr lang="en-IN"/>
+          </a:p>
+        </p:txBody>
       </p:sp>
       <p:sp>
         <p:nvSpPr>
@@ -12425,6 +13510,13 @@
             </a:outerShdw>
           </a:effectLst>
         </p:spPr>
+        <p:txBody>
+          <a:bodyPr/>
+          <a:lstStyle/>
+          <a:p>
+            <a:endParaRPr lang="en-IN"/>
+          </a:p>
+        </p:txBody>
       </p:sp>
       <p:sp>
         <p:nvSpPr>
@@ -12445,6 +13537,13 @@
           </a:solidFill>
           <a:ln/>
         </p:spPr>
+        <p:txBody>
+          <a:bodyPr/>
+          <a:lstStyle/>
+          <a:p>
+            <a:endParaRPr lang="en-IN"/>
+          </a:p>
+        </p:txBody>
       </p:sp>
       <p:sp>
         <p:nvSpPr>
@@ -12544,6 +13643,13 @@
             </a:outerShdw>
           </a:effectLst>
         </p:spPr>
+        <p:txBody>
+          <a:bodyPr/>
+          <a:lstStyle/>
+          <a:p>
+            <a:endParaRPr lang="en-IN"/>
+          </a:p>
+        </p:txBody>
       </p:sp>
       <p:sp>
         <p:nvSpPr>
@@ -12564,6 +13670,13 @@
           </a:solidFill>
           <a:ln/>
         </p:spPr>
+        <p:txBody>
+          <a:bodyPr/>
+          <a:lstStyle/>
+          <a:p>
+            <a:endParaRPr lang="en-IN"/>
+          </a:p>
+        </p:txBody>
       </p:sp>
       <p:sp>
         <p:nvSpPr>
@@ -12701,6 +13814,13 @@
           </a:solidFill>
           <a:ln/>
         </p:spPr>
+        <p:txBody>
+          <a:bodyPr/>
+          <a:lstStyle/>
+          <a:p>
+            <a:endParaRPr lang="en-IN"/>
+          </a:p>
+        </p:txBody>
       </p:sp>
       <p:sp>
         <p:nvSpPr>
@@ -12762,14 +13882,6 @@
             <a:pPr marL="0" indent="0">
               <a:buNone/>
             </a:pPr>
-            <a:r>
-              <a:rPr lang="en-US" sz="1000" i="1" dirty="0">
-                <a:solidFill>
-                  <a:srgbClr val="A8024F"/>
-                </a:solidFill>
-              </a:rPr>
-              <a:t>Customer journey from plan exploration to active policy</a:t>
-            </a:r>
             <a:endParaRPr lang="en-US" sz="1000" dirty="0"/>
           </a:p>
         </p:txBody>
@@ -12793,6 +13905,13 @@
           </a:solidFill>
           <a:ln/>
         </p:spPr>
+        <p:txBody>
+          <a:bodyPr/>
+          <a:lstStyle/>
+          <a:p>
+            <a:endParaRPr lang="en-IN"/>
+          </a:p>
+        </p:txBody>
       </p:sp>
       <p:sp>
         <p:nvSpPr>
@@ -12856,6 +13975,13 @@
             </a:outerShdw>
           </a:effectLst>
         </p:spPr>
+        <p:txBody>
+          <a:bodyPr/>
+          <a:lstStyle/>
+          <a:p>
+            <a:endParaRPr lang="en-IN"/>
+          </a:p>
+        </p:txBody>
       </p:sp>
       <p:sp>
         <p:nvSpPr>
@@ -12876,6 +14002,13 @@
           </a:solidFill>
           <a:ln/>
         </p:spPr>
+        <p:txBody>
+          <a:bodyPr/>
+          <a:lstStyle/>
+          <a:p>
+            <a:endParaRPr lang="en-IN"/>
+          </a:p>
+        </p:txBody>
       </p:sp>
       <p:sp>
         <p:nvSpPr>
@@ -13061,6 +14194,13 @@
             </a:outerShdw>
           </a:effectLst>
         </p:spPr>
+        <p:txBody>
+          <a:bodyPr/>
+          <a:lstStyle/>
+          <a:p>
+            <a:endParaRPr lang="en-IN"/>
+          </a:p>
+        </p:txBody>
       </p:sp>
       <p:sp>
         <p:nvSpPr>
@@ -13081,6 +14221,13 @@
           </a:solidFill>
           <a:ln/>
         </p:spPr>
+        <p:txBody>
+          <a:bodyPr/>
+          <a:lstStyle/>
+          <a:p>
+            <a:endParaRPr lang="en-IN"/>
+          </a:p>
+        </p:txBody>
       </p:sp>
       <p:sp>
         <p:nvSpPr>
@@ -13266,6 +14413,13 @@
             </a:outerShdw>
           </a:effectLst>
         </p:spPr>
+        <p:txBody>
+          <a:bodyPr/>
+          <a:lstStyle/>
+          <a:p>
+            <a:endParaRPr lang="en-IN"/>
+          </a:p>
+        </p:txBody>
       </p:sp>
       <p:sp>
         <p:nvSpPr>
@@ -13286,6 +14440,13 @@
           </a:solidFill>
           <a:ln/>
         </p:spPr>
+        <p:txBody>
+          <a:bodyPr/>
+          <a:lstStyle/>
+          <a:p>
+            <a:endParaRPr lang="en-IN"/>
+          </a:p>
+        </p:txBody>
       </p:sp>
       <p:sp>
         <p:nvSpPr>
@@ -13435,6 +14596,13 @@
             </a:outerShdw>
           </a:effectLst>
         </p:spPr>
+        <p:txBody>
+          <a:bodyPr/>
+          <a:lstStyle/>
+          <a:p>
+            <a:endParaRPr lang="en-IN"/>
+          </a:p>
+        </p:txBody>
       </p:sp>
       <p:sp>
         <p:nvSpPr>
@@ -13455,6 +14623,13 @@
           </a:solidFill>
           <a:ln/>
         </p:spPr>
+        <p:txBody>
+          <a:bodyPr/>
+          <a:lstStyle/>
+          <a:p>
+            <a:endParaRPr lang="en-IN"/>
+          </a:p>
+        </p:txBody>
       </p:sp>
       <p:sp>
         <p:nvSpPr>
@@ -13640,6 +14815,13 @@
             </a:outerShdw>
           </a:effectLst>
         </p:spPr>
+        <p:txBody>
+          <a:bodyPr/>
+          <a:lstStyle/>
+          <a:p>
+            <a:endParaRPr lang="en-IN"/>
+          </a:p>
+        </p:txBody>
       </p:sp>
       <p:sp>
         <p:nvSpPr>
@@ -13660,6 +14842,13 @@
           </a:solidFill>
           <a:ln/>
         </p:spPr>
+        <p:txBody>
+          <a:bodyPr/>
+          <a:lstStyle/>
+          <a:p>
+            <a:endParaRPr lang="en-IN"/>
+          </a:p>
+        </p:txBody>
       </p:sp>
       <p:sp>
         <p:nvSpPr>
@@ -13845,6 +15034,13 @@
             </a:outerShdw>
           </a:effectLst>
         </p:spPr>
+        <p:txBody>
+          <a:bodyPr/>
+          <a:lstStyle/>
+          <a:p>
+            <a:endParaRPr lang="en-IN"/>
+          </a:p>
+        </p:txBody>
       </p:sp>
       <p:sp>
         <p:nvSpPr>
@@ -13865,6 +15061,13 @@
           </a:solidFill>
           <a:ln/>
         </p:spPr>
+        <p:txBody>
+          <a:bodyPr/>
+          <a:lstStyle/>
+          <a:p>
+            <a:endParaRPr lang="en-IN"/>
+          </a:p>
+        </p:txBody>
       </p:sp>
       <p:sp>
         <p:nvSpPr>
@@ -14007,6 +15210,13 @@
           </a:solidFill>
           <a:ln/>
         </p:spPr>
+        <p:txBody>
+          <a:bodyPr/>
+          <a:lstStyle/>
+          <a:p>
+            <a:endParaRPr lang="en-IN"/>
+          </a:p>
+        </p:txBody>
       </p:sp>
       <p:sp>
         <p:nvSpPr>
@@ -14108,6 +15318,13 @@
           </a:solidFill>
           <a:ln/>
         </p:spPr>
+        <p:txBody>
+          <a:bodyPr/>
+          <a:lstStyle/>
+          <a:p>
+            <a:endParaRPr lang="en-IN"/>
+          </a:p>
+        </p:txBody>
       </p:sp>
       <p:sp>
         <p:nvSpPr>
@@ -14169,14 +15386,6 @@
             <a:pPr marL="0" indent="0">
               <a:buNone/>
             </a:pPr>
-            <a:r>
-              <a:rPr lang="en-US" sz="1000" i="1" dirty="0">
-                <a:solidFill>
-                  <a:srgbClr val="A8024F"/>
-                </a:solidFill>
-              </a:rPr>
-              <a:t>End-to-end claim lifecycle from submission to settlement</a:t>
-            </a:r>
             <a:endParaRPr lang="en-US" sz="1000" dirty="0"/>
           </a:p>
         </p:txBody>
@@ -14200,6 +15409,13 @@
           </a:solidFill>
           <a:ln/>
         </p:spPr>
+        <p:txBody>
+          <a:bodyPr/>
+          <a:lstStyle/>
+          <a:p>
+            <a:endParaRPr lang="en-IN"/>
+          </a:p>
+        </p:txBody>
       </p:sp>
       <p:sp>
         <p:nvSpPr>
@@ -14263,6 +15479,13 @@
             </a:outerShdw>
           </a:effectLst>
         </p:spPr>
+        <p:txBody>
+          <a:bodyPr/>
+          <a:lstStyle/>
+          <a:p>
+            <a:endParaRPr lang="en-IN"/>
+          </a:p>
+        </p:txBody>
       </p:sp>
       <p:sp>
         <p:nvSpPr>
@@ -14398,6 +15621,13 @@
             </a:outerShdw>
           </a:effectLst>
         </p:spPr>
+        <p:txBody>
+          <a:bodyPr/>
+          <a:lstStyle/>
+          <a:p>
+            <a:endParaRPr lang="en-IN"/>
+          </a:p>
+        </p:txBody>
       </p:sp>
       <p:sp>
         <p:nvSpPr>
@@ -14533,6 +15763,13 @@
             </a:outerShdw>
           </a:effectLst>
         </p:spPr>
+        <p:txBody>
+          <a:bodyPr/>
+          <a:lstStyle/>
+          <a:p>
+            <a:endParaRPr lang="en-IN"/>
+          </a:p>
+        </p:txBody>
       </p:sp>
       <p:sp>
         <p:nvSpPr>
@@ -14668,6 +15905,13 @@
             </a:outerShdw>
           </a:effectLst>
         </p:spPr>
+        <p:txBody>
+          <a:bodyPr/>
+          <a:lstStyle/>
+          <a:p>
+            <a:endParaRPr lang="en-IN"/>
+          </a:p>
+        </p:txBody>
       </p:sp>
       <p:sp>
         <p:nvSpPr>
@@ -14803,6 +16047,13 @@
             </a:outerShdw>
           </a:effectLst>
         </p:spPr>
+        <p:txBody>
+          <a:bodyPr/>
+          <a:lstStyle/>
+          <a:p>
+            <a:endParaRPr lang="en-IN"/>
+          </a:p>
+        </p:txBody>
       </p:sp>
       <p:sp>
         <p:nvSpPr>
@@ -14938,6 +16189,13 @@
             </a:outerShdw>
           </a:effectLst>
         </p:spPr>
+        <p:txBody>
+          <a:bodyPr/>
+          <a:lstStyle/>
+          <a:p>
+            <a:endParaRPr lang="en-IN"/>
+          </a:p>
+        </p:txBody>
       </p:sp>
       <p:sp>
         <p:nvSpPr>
@@ -14958,6 +16216,13 @@
           </a:solidFill>
           <a:ln/>
         </p:spPr>
+        <p:txBody>
+          <a:bodyPr/>
+          <a:lstStyle/>
+          <a:p>
+            <a:endParaRPr lang="en-IN"/>
+          </a:p>
+        </p:txBody>
       </p:sp>
       <p:sp>
         <p:nvSpPr>
@@ -15165,6 +16430,13 @@
             </a:outerShdw>
           </a:effectLst>
         </p:spPr>
+        <p:txBody>
+          <a:bodyPr/>
+          <a:lstStyle/>
+          <a:p>
+            <a:endParaRPr lang="en-IN"/>
+          </a:p>
+        </p:txBody>
       </p:sp>
       <p:sp>
         <p:nvSpPr>
@@ -15185,6 +16457,13 @@
           </a:solidFill>
           <a:ln/>
         </p:spPr>
+        <p:txBody>
+          <a:bodyPr/>
+          <a:lstStyle/>
+          <a:p>
+            <a:endParaRPr lang="en-IN"/>
+          </a:p>
+        </p:txBody>
       </p:sp>
       <p:sp>
         <p:nvSpPr>
@@ -15356,6 +16635,13 @@
             </a:outerShdw>
           </a:effectLst>
         </p:spPr>
+        <p:txBody>
+          <a:bodyPr/>
+          <a:lstStyle/>
+          <a:p>
+            <a:endParaRPr lang="en-IN"/>
+          </a:p>
+        </p:txBody>
       </p:sp>
       <p:sp>
         <p:nvSpPr>
@@ -15455,6 +16741,13 @@
             </a:outerShdw>
           </a:effectLst>
         </p:spPr>
+        <p:txBody>
+          <a:bodyPr/>
+          <a:lstStyle/>
+          <a:p>
+            <a:endParaRPr lang="en-IN"/>
+          </a:p>
+        </p:txBody>
       </p:sp>
       <p:sp>
         <p:nvSpPr>
@@ -15592,6 +16885,13 @@
           </a:solidFill>
           <a:ln/>
         </p:spPr>
+        <p:txBody>
+          <a:bodyPr/>
+          <a:lstStyle/>
+          <a:p>
+            <a:endParaRPr lang="en-IN"/>
+          </a:p>
+        </p:txBody>
       </p:sp>
       <p:sp>
         <p:nvSpPr>
@@ -15653,14 +16953,6 @@
             <a:pPr marL="0" indent="0">
               <a:buNone/>
             </a:pPr>
-            <a:r>
-              <a:rPr lang="en-US" sz="1000" i="1" dirty="0">
-                <a:solidFill>
-                  <a:srgbClr val="A8024F"/>
-                </a:solidFill>
-              </a:rPr>
-              <a:t>Automated premium management with real-time alerts</a:t>
-            </a:r>
             <a:endParaRPr lang="en-US" sz="1000" dirty="0"/>
           </a:p>
         </p:txBody>
@@ -15684,6 +16976,13 @@
           </a:solidFill>
           <a:ln/>
         </p:spPr>
+        <p:txBody>
+          <a:bodyPr/>
+          <a:lstStyle/>
+          <a:p>
+            <a:endParaRPr lang="en-IN"/>
+          </a:p>
+        </p:txBody>
       </p:sp>
       <p:sp>
         <p:nvSpPr>
@@ -15747,6 +17046,13 @@
             </a:outerShdw>
           </a:effectLst>
         </p:spPr>
+        <p:txBody>
+          <a:bodyPr/>
+          <a:lstStyle/>
+          <a:p>
+            <a:endParaRPr lang="en-IN"/>
+          </a:p>
+        </p:txBody>
       </p:sp>
       <p:sp>
         <p:nvSpPr>
@@ -15767,6 +17073,13 @@
           </a:solidFill>
           <a:ln/>
         </p:spPr>
+        <p:txBody>
+          <a:bodyPr/>
+          <a:lstStyle/>
+          <a:p>
+            <a:endParaRPr lang="en-IN"/>
+          </a:p>
+        </p:txBody>
       </p:sp>
       <p:sp>
         <p:nvSpPr>
@@ -15823,6 +17136,13 @@
           </a:solidFill>
           <a:ln/>
         </p:spPr>
+        <p:txBody>
+          <a:bodyPr/>
+          <a:lstStyle/>
+          <a:p>
+            <a:endParaRPr lang="en-IN"/>
+          </a:p>
+        </p:txBody>
       </p:sp>
       <p:sp>
         <p:nvSpPr>
@@ -15915,6 +17235,13 @@
           </a:solidFill>
           <a:ln/>
         </p:spPr>
+        <p:txBody>
+          <a:bodyPr/>
+          <a:lstStyle/>
+          <a:p>
+            <a:endParaRPr lang="en-IN"/>
+          </a:p>
+        </p:txBody>
       </p:sp>
       <p:sp>
         <p:nvSpPr>
@@ -16007,6 +17334,13 @@
           </a:solidFill>
           <a:ln/>
         </p:spPr>
+        <p:txBody>
+          <a:bodyPr/>
+          <a:lstStyle/>
+          <a:p>
+            <a:endParaRPr lang="en-IN"/>
+          </a:p>
+        </p:txBody>
       </p:sp>
       <p:sp>
         <p:nvSpPr>
@@ -16099,6 +17433,13 @@
           </a:solidFill>
           <a:ln/>
         </p:spPr>
+        <p:txBody>
+          <a:bodyPr/>
+          <a:lstStyle/>
+          <a:p>
+            <a:endParaRPr lang="en-IN"/>
+          </a:p>
+        </p:txBody>
       </p:sp>
       <p:sp>
         <p:nvSpPr>
@@ -16191,6 +17532,13 @@
           </a:solidFill>
           <a:ln/>
         </p:spPr>
+        <p:txBody>
+          <a:bodyPr/>
+          <a:lstStyle/>
+          <a:p>
+            <a:endParaRPr lang="en-IN"/>
+          </a:p>
+        </p:txBody>
       </p:sp>
       <p:sp>
         <p:nvSpPr>
@@ -16283,6 +17631,13 @@
           </a:solidFill>
           <a:ln/>
         </p:spPr>
+        <p:txBody>
+          <a:bodyPr/>
+          <a:lstStyle/>
+          <a:p>
+            <a:endParaRPr lang="en-IN"/>
+          </a:p>
+        </p:txBody>
       </p:sp>
       <p:sp>
         <p:nvSpPr>
@@ -16382,6 +17737,13 @@
             </a:outerShdw>
           </a:effectLst>
         </p:spPr>
+        <p:txBody>
+          <a:bodyPr/>
+          <a:lstStyle/>
+          <a:p>
+            <a:endParaRPr lang="en-IN"/>
+          </a:p>
+        </p:txBody>
       </p:sp>
       <p:sp>
         <p:nvSpPr>
@@ -16402,6 +17764,13 @@
           </a:solidFill>
           <a:ln/>
         </p:spPr>
+        <p:txBody>
+          <a:bodyPr/>
+          <a:lstStyle/>
+          <a:p>
+            <a:endParaRPr lang="en-IN"/>
+          </a:p>
+        </p:txBody>
       </p:sp>
       <p:sp>
         <p:nvSpPr>
@@ -16458,6 +17827,13 @@
           </a:solidFill>
           <a:ln/>
         </p:spPr>
+        <p:txBody>
+          <a:bodyPr/>
+          <a:lstStyle/>
+          <a:p>
+            <a:endParaRPr lang="en-IN"/>
+          </a:p>
+        </p:txBody>
       </p:sp>
       <p:sp>
         <p:nvSpPr>
@@ -16478,6 +17854,13 @@
           </a:solidFill>
           <a:ln/>
         </p:spPr>
+        <p:txBody>
+          <a:bodyPr/>
+          <a:lstStyle/>
+          <a:p>
+            <a:endParaRPr lang="en-IN"/>
+          </a:p>
+        </p:txBody>
       </p:sp>
       <p:sp>
         <p:nvSpPr>
@@ -16570,6 +17953,13 @@
           </a:solidFill>
           <a:ln/>
         </p:spPr>
+        <p:txBody>
+          <a:bodyPr/>
+          <a:lstStyle/>
+          <a:p>
+            <a:endParaRPr lang="en-IN"/>
+          </a:p>
+        </p:txBody>
       </p:sp>
       <p:sp>
         <p:nvSpPr>
@@ -16590,6 +17980,13 @@
           </a:solidFill>
           <a:ln/>
         </p:spPr>
+        <p:txBody>
+          <a:bodyPr/>
+          <a:lstStyle/>
+          <a:p>
+            <a:endParaRPr lang="en-IN"/>
+          </a:p>
+        </p:txBody>
       </p:sp>
       <p:sp>
         <p:nvSpPr>
@@ -16682,6 +18079,13 @@
           </a:solidFill>
           <a:ln/>
         </p:spPr>
+        <p:txBody>
+          <a:bodyPr/>
+          <a:lstStyle/>
+          <a:p>
+            <a:endParaRPr lang="en-IN"/>
+          </a:p>
+        </p:txBody>
       </p:sp>
       <p:sp>
         <p:nvSpPr>
@@ -16702,6 +18106,13 @@
           </a:solidFill>
           <a:ln/>
         </p:spPr>
+        <p:txBody>
+          <a:bodyPr/>
+          <a:lstStyle/>
+          <a:p>
+            <a:endParaRPr lang="en-IN"/>
+          </a:p>
+        </p:txBody>
       </p:sp>
       <p:sp>
         <p:nvSpPr>
@@ -16794,6 +18205,13 @@
           </a:solidFill>
           <a:ln/>
         </p:spPr>
+        <p:txBody>
+          <a:bodyPr/>
+          <a:lstStyle/>
+          <a:p>
+            <a:endParaRPr lang="en-IN"/>
+          </a:p>
+        </p:txBody>
       </p:sp>
       <p:sp>
         <p:nvSpPr>
@@ -16814,6 +18232,13 @@
           </a:solidFill>
           <a:ln/>
         </p:spPr>
+        <p:txBody>
+          <a:bodyPr/>
+          <a:lstStyle/>
+          <a:p>
+            <a:endParaRPr lang="en-IN"/>
+          </a:p>
+        </p:txBody>
       </p:sp>
       <p:sp>
         <p:nvSpPr>
@@ -16906,6 +18331,13 @@
           </a:solidFill>
           <a:ln/>
         </p:spPr>
+        <p:txBody>
+          <a:bodyPr/>
+          <a:lstStyle/>
+          <a:p>
+            <a:endParaRPr lang="en-IN"/>
+          </a:p>
+        </p:txBody>
       </p:sp>
       <p:sp>
         <p:nvSpPr>
@@ -16926,6 +18358,13 @@
           </a:solidFill>
           <a:ln/>
         </p:spPr>
+        <p:txBody>
+          <a:bodyPr/>
+          <a:lstStyle/>
+          <a:p>
+            <a:endParaRPr lang="en-IN"/>
+          </a:p>
+        </p:txBody>
       </p:sp>
       <p:sp>
         <p:nvSpPr>
@@ -17018,6 +18457,13 @@
           </a:solidFill>
           <a:ln/>
         </p:spPr>
+        <p:txBody>
+          <a:bodyPr/>
+          <a:lstStyle/>
+          <a:p>
+            <a:endParaRPr lang="en-IN"/>
+          </a:p>
+        </p:txBody>
       </p:sp>
       <p:sp>
         <p:nvSpPr>
@@ -17038,6 +18484,13 @@
           </a:solidFill>
           <a:ln/>
         </p:spPr>
+        <p:txBody>
+          <a:bodyPr/>
+          <a:lstStyle/>
+          <a:p>
+            <a:endParaRPr lang="en-IN"/>
+          </a:p>
+        </p:txBody>
       </p:sp>
       <p:sp>
         <p:nvSpPr>
@@ -17167,6 +18620,13 @@
           </a:solidFill>
           <a:ln/>
         </p:spPr>
+        <p:txBody>
+          <a:bodyPr/>
+          <a:lstStyle/>
+          <a:p>
+            <a:endParaRPr lang="en-IN"/>
+          </a:p>
+        </p:txBody>
       </p:sp>
       <p:sp>
         <p:nvSpPr>
@@ -17254,6 +18714,13 @@
             </a:outerShdw>
           </a:effectLst>
         </p:spPr>
+        <p:txBody>
+          <a:bodyPr/>
+          <a:lstStyle/>
+          <a:p>
+            <a:endParaRPr lang="en-IN"/>
+          </a:p>
+        </p:txBody>
       </p:sp>
       <p:sp>
         <p:nvSpPr>
@@ -17274,6 +18741,13 @@
           </a:solidFill>
           <a:ln/>
         </p:spPr>
+        <p:txBody>
+          <a:bodyPr/>
+          <a:lstStyle/>
+          <a:p>
+            <a:endParaRPr lang="en-IN"/>
+          </a:p>
+        </p:txBody>
       </p:sp>
       <p:sp>
         <p:nvSpPr>
@@ -17469,6 +18943,13 @@
             </a:outerShdw>
           </a:effectLst>
         </p:spPr>
+        <p:txBody>
+          <a:bodyPr/>
+          <a:lstStyle/>
+          <a:p>
+            <a:endParaRPr lang="en-IN"/>
+          </a:p>
+        </p:txBody>
       </p:sp>
       <p:sp>
         <p:nvSpPr>
@@ -17489,6 +18970,13 @@
           </a:solidFill>
           <a:ln/>
         </p:spPr>
+        <p:txBody>
+          <a:bodyPr/>
+          <a:lstStyle/>
+          <a:p>
+            <a:endParaRPr lang="en-IN"/>
+          </a:p>
+        </p:txBody>
       </p:sp>
       <p:sp>
         <p:nvSpPr>
@@ -17509,6 +18997,13 @@
           </a:solidFill>
           <a:ln/>
         </p:spPr>
+        <p:txBody>
+          <a:bodyPr/>
+          <a:lstStyle/>
+          <a:p>
+            <a:endParaRPr lang="en-IN"/>
+          </a:p>
+        </p:txBody>
       </p:sp>
       <p:pic>
         <p:nvPicPr>
@@ -17704,6 +19199,13 @@
             </a:outerShdw>
           </a:effectLst>
         </p:spPr>
+        <p:txBody>
+          <a:bodyPr/>
+          <a:lstStyle/>
+          <a:p>
+            <a:endParaRPr lang="en-IN"/>
+          </a:p>
+        </p:txBody>
       </p:sp>
       <p:sp>
         <p:nvSpPr>
@@ -17724,6 +19226,13 @@
           </a:solidFill>
           <a:ln/>
         </p:spPr>
+        <p:txBody>
+          <a:bodyPr/>
+          <a:lstStyle/>
+          <a:p>
+            <a:endParaRPr lang="en-IN"/>
+          </a:p>
+        </p:txBody>
       </p:sp>
       <p:sp>
         <p:nvSpPr>
@@ -17744,6 +19253,13 @@
           </a:solidFill>
           <a:ln/>
         </p:spPr>
+        <p:txBody>
+          <a:bodyPr/>
+          <a:lstStyle/>
+          <a:p>
+            <a:endParaRPr lang="en-IN"/>
+          </a:p>
+        </p:txBody>
       </p:sp>
       <p:pic>
         <p:nvPicPr>
@@ -17967,6 +19483,13 @@
             </a:outerShdw>
           </a:effectLst>
         </p:spPr>
+        <p:txBody>
+          <a:bodyPr/>
+          <a:lstStyle/>
+          <a:p>
+            <a:endParaRPr lang="en-IN"/>
+          </a:p>
+        </p:txBody>
       </p:sp>
       <p:sp>
         <p:nvSpPr>
@@ -17987,6 +19510,13 @@
           </a:solidFill>
           <a:ln/>
         </p:spPr>
+        <p:txBody>
+          <a:bodyPr/>
+          <a:lstStyle/>
+          <a:p>
+            <a:endParaRPr lang="en-IN"/>
+          </a:p>
+        </p:txBody>
       </p:sp>
       <p:sp>
         <p:nvSpPr>
@@ -18007,6 +19537,13 @@
           </a:solidFill>
           <a:ln/>
         </p:spPr>
+        <p:txBody>
+          <a:bodyPr/>
+          <a:lstStyle/>
+          <a:p>
+            <a:endParaRPr lang="en-IN"/>
+          </a:p>
+        </p:txBody>
       </p:sp>
       <p:pic>
         <p:nvPicPr>
@@ -18216,6 +19753,13 @@
             </a:outerShdw>
           </a:effectLst>
         </p:spPr>
+        <p:txBody>
+          <a:bodyPr/>
+          <a:lstStyle/>
+          <a:p>
+            <a:endParaRPr lang="en-IN"/>
+          </a:p>
+        </p:txBody>
       </p:sp>
       <p:sp>
         <p:nvSpPr>
@@ -18236,6 +19780,13 @@
           </a:solidFill>
           <a:ln/>
         </p:spPr>
+        <p:txBody>
+          <a:bodyPr/>
+          <a:lstStyle/>
+          <a:p>
+            <a:endParaRPr lang="en-IN"/>
+          </a:p>
+        </p:txBody>
       </p:sp>
       <p:sp>
         <p:nvSpPr>
@@ -18256,6 +19807,13 @@
           </a:solidFill>
           <a:ln/>
         </p:spPr>
+        <p:txBody>
+          <a:bodyPr/>
+          <a:lstStyle/>
+          <a:p>
+            <a:endParaRPr lang="en-IN"/>
+          </a:p>
+        </p:txBody>
       </p:sp>
       <p:pic>
         <p:nvPicPr>
@@ -18479,6 +20037,13 @@
             </a:outerShdw>
           </a:effectLst>
         </p:spPr>
+        <p:txBody>
+          <a:bodyPr/>
+          <a:lstStyle/>
+          <a:p>
+            <a:endParaRPr lang="en-IN"/>
+          </a:p>
+        </p:txBody>
       </p:sp>
       <p:sp>
         <p:nvSpPr>
@@ -18499,6 +20064,13 @@
           </a:solidFill>
           <a:ln/>
         </p:spPr>
+        <p:txBody>
+          <a:bodyPr/>
+          <a:lstStyle/>
+          <a:p>
+            <a:endParaRPr lang="en-IN"/>
+          </a:p>
+        </p:txBody>
       </p:sp>
       <p:sp>
         <p:nvSpPr>
@@ -18519,6 +20091,13 @@
           </a:solidFill>
           <a:ln/>
         </p:spPr>
+        <p:txBody>
+          <a:bodyPr/>
+          <a:lstStyle/>
+          <a:p>
+            <a:endParaRPr lang="en-IN"/>
+          </a:p>
+        </p:txBody>
       </p:sp>
       <p:pic>
         <p:nvPicPr>
@@ -18728,6 +20307,13 @@
             </a:outerShdw>
           </a:effectLst>
         </p:spPr>
+        <p:txBody>
+          <a:bodyPr/>
+          <a:lstStyle/>
+          <a:p>
+            <a:endParaRPr lang="en-IN"/>
+          </a:p>
+        </p:txBody>
       </p:sp>
       <p:sp>
         <p:nvSpPr>
@@ -18748,6 +20334,13 @@
           </a:solidFill>
           <a:ln/>
         </p:spPr>
+        <p:txBody>
+          <a:bodyPr/>
+          <a:lstStyle/>
+          <a:p>
+            <a:endParaRPr lang="en-IN"/>
+          </a:p>
+        </p:txBody>
       </p:sp>
       <p:sp>
         <p:nvSpPr>
@@ -18768,6 +20361,13 @@
           </a:solidFill>
           <a:ln/>
         </p:spPr>
+        <p:txBody>
+          <a:bodyPr/>
+          <a:lstStyle/>
+          <a:p>
+            <a:endParaRPr lang="en-IN"/>
+          </a:p>
+        </p:txBody>
       </p:sp>
       <p:pic>
         <p:nvPicPr>
@@ -18984,6 +20584,13 @@
           </a:solidFill>
           <a:ln/>
         </p:spPr>
+        <p:txBody>
+          <a:bodyPr/>
+          <a:lstStyle/>
+          <a:p>
+            <a:endParaRPr lang="en-IN"/>
+          </a:p>
+        </p:txBody>
       </p:sp>
       <p:sp>
         <p:nvSpPr>

</xml_diff>